<commit_message>
Fix repair logic (inspect-only never triggers Replace+R&I), simplify Model Lab caption to the 150-set ceiling, propagate KPI 206/379
- repair_logic: a damage whose only explicit action is pruefen/kalibrieren no
  longer gets a severity-derived ERSETZEN or its R&I cascade (fixes ~8 cases where
  'just inspect' became 'replace + remove/install').
- Regenerated cases.json/aggregates.json: replacements 216->206, R&I 389->379.
- Model Lab caption now cites only the 88.7% ceiling of the 150-case shootout.

Co-Authored-By: Claude Opus 4.8 <noreply@anthropic.com>
</commit_message>
<xml_diff>
--- a/Data/Damage_Intelligence_EN_v2.pptx
+++ b/Data/Damage_Intelligence_EN_v2.pptx
@@ -1555,7 +1555,15 @@
           <c:idx val="0"/>
           <c:order val="0"/>
           <c:tx>
-            <c:v>Dossiers</c:v>
+            <c:strRef>
+              <c:f>Sheet1!$B$1</c:f>
+              <c:strCache>
+                <c:ptCount val="1"/>
+                <c:pt idx="0">
+                  <c:v/>
+                </c:pt>
+              </c:strCache>
+            </c:strRef>
           </c:tx>
           <c:spPr>
             <a:solidFill xmlns:a="http://schemas.openxmlformats.org/drawingml/2006/main">
@@ -1564,38 +1572,38 @@
           </c:spPr>
           <c:cat>
             <c:strRef>
-              <c:f>'Chart Data'!$A$2:$A$8</c:f>
+              <c:f>Sheet1!$A$2:$A$8</c:f>
               <c:strCache>
                 <c:ptCount val="7"/>
                 <c:pt idx="0">
-                  <c:v>Stationnement</c:v>
+                  <c:v>Parking</c:v>
                 </c:pt>
                 <c:pt idx="1">
-                  <c:v>Manœuvre</c:v>
+                  <c:v>Manoeuvring</c:v>
                 </c:pt>
                 <c:pt idx="2">
-                  <c:v>Collision arrière</c:v>
+                  <c:v>Rear-end collision</c:v>
                 </c:pt>
                 <c:pt idx="3">
-                  <c:v>Gravillons</c:v>
+                  <c:v>Stone chip</c:v>
                 </c:pt>
                 <c:pt idx="4">
-                  <c:v>Grêle</c:v>
+                  <c:v>Hail</c:v>
                 </c:pt>
                 <c:pt idx="5">
-                  <c:v>Vandalisme</c:v>
+                  <c:v>Vandalism</c:v>
                 </c:pt>
                 <c:pt idx="6">
-                  <c:v>Animal</c:v>
+                  <c:v>Wildlife</c:v>
                 </c:pt>
               </c:strCache>
             </c:strRef>
           </c:cat>
           <c:val>
             <c:numRef>
-              <c:f>'Chart Data'!$B$2:$B$8</c:f>
+              <c:f>Sheet1!$B$2:$B$8</c:f>
               <c:numCache>
-                <c:formatCode>0</c:formatCode>
+                <c:formatCode>General</c:formatCode>
                 <c:ptCount val="7"/>
                 <c:pt idx="0">
                   <c:v>110</c:v>
@@ -4490,7 +4498,7 @@
                 <a:ea typeface="Arial"/>
                 <a:cs typeface="Arial"/>
               </a:rPr>
-              <a:t>99,9 %</a:t>
+              <a:t>99.9%</a:t>
             </a:r>
           </a:p>
         </p:txBody>
@@ -5105,7 +5113,7 @@
                 <a:ea typeface="Arial"/>
                 <a:cs typeface="Arial"/>
               </a:rPr>
-              <a:t>¹ Insurance: 434 damage cases. Severity: 284 train / 150 test. On the full 977: DeepSeek 68.7% vs a 79.5% data-ceiling.</a:t>
+              <a:t>¹ Insurance: 434 damage cases. Severity: 284 train / 150 test. On the 434 damage cases: DeepSeek severity 68.7% vs a 79.5% data-ceiling.</a:t>
             </a:r>
           </a:p>
         </p:txBody>

</xml_diff>

<commit_message>
Add project README + requirements, tidy repo for public sharing
Add top-level README (problem, architecture "LLM reads / code decides", results, run steps, limitations, repo map) and Work/pipeline/requirements.txt derived from the pipeline imports. Ignore Office temp files and the local deploy snapshot, and remove a tracked temp lock file. Commit the final English decks.

Co-Authored-By: Claude Opus 4.8 <noreply@anthropic.com>
</commit_message>
<xml_diff>
--- a/Data/Damage_Intelligence_EN_v2.pptx
+++ b/Data/Damage_Intelligence_EN_v2.pptx
@@ -112,6 +112,11 @@
       </a:defRPr>
     </a:lvl9pPr>
   </p:defaultTextStyle>
+  <p:extLst>
+    <p:ext uri="{EFAFB233-063F-42B5-8137-9DF3F51BA10A}">
+      <p15:sldGuideLst xmlns:p15="http://schemas.microsoft.com/office/powerpoint/2012/main"/>
+    </p:ext>
+  </p:extLst>
 </p:presentation>
 </file>
 
@@ -604,7 +609,17 @@
           <a:lstStyle/>
           <a:p>
             <a:r>
-              <a:t>Opening pitch: "Before we dive in, here's the live link so you can follow along: wolf-day-damage.vercel.app/dashboard. I'll walk you through what we built, then we'll review the dashboard together — it's designed for the workshop mechanic."</a:t>
+              <a:t>Prefer the product to the pipeline? Follow along on the live dashboard.</a:t>
+            </a:r>
+          </a:p>
+          <a:p>
+            <a:r>
+              <a:t>- We built this for a German car dealership group.</a:t>
+            </a:r>
+          </a:p>
+          <a:p>
+            <a:r>
+              <a:t>- I'll walk you through what we built, then we review the dashboard together — it's made for the workshop mechanic.</a:t>
             </a:r>
           </a:p>
         </p:txBody>
@@ -681,33 +696,27 @@
           <a:lstStyle/>
           <a:p>
             <a:r>
-              <a:t>50 seconds. The AI fills a strict schema and must keep a German excerpt justifying each damage. The closed vocabulary links a part and its side to the visualisation. Statuses come from structured data. An explicit action in the note takes priority; otherwise, rules propose the operations. Remove-and-install (R&amp;I) uses a dependency table — it separates a damaged part from a neighbouring part that must be taken off. The per-case cache avoids redoing successful calls. Failures are flagged; calls retry with increasing back-off. Passing format validation does not prove the meaning is correct.</a:t>
-            </a:r>
-          </a:p>
-          <a:p/>
-          <a:p>
-            <a:r>
-              <a:t>Local sources:</a:t>
-            </a:r>
-          </a:p>
-          <a:p>
-            <a:r>
-              <a:t>Work/pipeline/extract.py</a:t>
-            </a:r>
-          </a:p>
-          <a:p>
-            <a:r>
-              <a:t>Work/pipeline/schema.py</a:t>
-            </a:r>
-          </a:p>
-          <a:p>
-            <a:r>
-              <a:t>Work/pipeline/repair_logic.py</a:t>
-            </a:r>
-          </a:p>
-          <a:p>
-            <a:r>
-              <a:t>Work/pipeline/build_dataset.py</a:t>
+              <a:t>The hard part isn't drawing a car — it's turning messy free-text German into reliable structure.</a:t>
+            </a:r>
+          </a:p>
+          <a:p>
+            <a:r>
+              <a:t>- One extraction feeds both deliverables.</a:t>
+            </a:r>
+          </a:p>
+          <a:p>
+            <a:r>
+              <a:t>- The AI only reads the note into a strict schema, keeping a German quote for each damage.</a:t>
+            </a:r>
+          </a:p>
+          <a:p>
+            <a:r>
+              <a:t>- Deterministic rules, not the AI, decide the operations and the remove-and-install parts.</a:t>
+            </a:r>
+          </a:p>
+          <a:p>
+            <a:r>
+              <a:t>- Idempotent: per-case cache, retry on failure. Passing validation isn't proof of meaning — that's why we score it.</a:t>
             </a:r>
           </a:p>
         </p:txBody>
@@ -784,33 +793,27 @@
           <a:lstStyle/>
           <a:p>
             <a:r>
-              <a:t>45 seconds. Show the German sentence before the colours. The note says the windscreen cannot be repaired and needs replacing. The windscreen shows orange, which here matches the extracted medium severity. Blue marks a trim piece to remove and reinstall per the business rule, not a second damage. This example is from the development pilot: it illustrates how it works, not proof of generalisation. The prototype also has a 3D view, but the capture uses the 2D view, clearer for explaining the data-to-zone link. Local demo: /dashboard/cases/820002/.</a:t>
-            </a:r>
-          </a:p>
-          <a:p/>
-          <a:p>
-            <a:r>
-              <a:t>Local sources:</a:t>
-            </a:r>
-          </a:p>
-          <a:p>
-            <a:r>
-              <a:t>Data/frontend/public/data/cases.json</a:t>
-            </a:r>
-          </a:p>
-          <a:p>
-            <a:r>
-              <a:t>Data/frontend/src/sections/damage/car-diagram.tsx</a:t>
-            </a:r>
-          </a:p>
-          <a:p>
-            <a:r>
-              <a:t>Work/pipeline/repair_logic.py</a:t>
-            </a:r>
-          </a:p>
-          <a:p>
-            <a:r>
-              <a:t>Work/pipeline/ml_common.py</a:t>
+              <a:t>Show the German sentence first, then the colours.</a:t>
+            </a:r>
+          </a:p>
+          <a:p>
+            <a:r>
+              <a:t>- Case 820002: the note says the windscreen can't be repaired and needs replacing → orange (medium severity).</a:t>
+            </a:r>
+          </a:p>
+          <a:p>
+            <a:r>
+              <a:t>- Blue = a trim piece to remove and reinstall, from the rule — not a second damage.</a:t>
+            </a:r>
+          </a:p>
+          <a:p>
+            <a:r>
+              <a:t>- Every coloured region traces back to an exact German quote.</a:t>
+            </a:r>
+          </a:p>
+          <a:p>
+            <a:r>
+              <a:t>- 2D here for clarity; there's also a 3D view.</a:t>
             </a:r>
           </a:p>
         </p:txBody>
@@ -887,28 +890,22 @@
           <a:lstStyle/>
           <a:p>
             <a:r>
-              <a:t>40 seconds. The corpus has 550 service cases and 450 damage cases. Among the latter, 110 are parking and 76 are manoeuvring, i.e. 186/450 = 41.3%. A business angle would be to look at their bodywork load, but we do not measure an operational gain here. The 668 cases on the open worklist have a median age of 150 days as of 18 September 2026. That is time since creation, not repair time, and some statuses may need checking. The observations describe this synthetic set, with no extrapolation to the market. The source notes stay in German.</a:t>
-            </a:r>
-          </a:p>
-          <a:p/>
-          <a:p>
-            <a:r>
-              <a:t>Local sources:</a:t>
-            </a:r>
-          </a:p>
-          <a:p>
-            <a:r>
-              <a:t>Data/frontend/public/data/aggregates.json</a:t>
-            </a:r>
-          </a:p>
-          <a:p>
-            <a:r>
-              <a:t>Work/pipeline/build_dataset.py</a:t>
-            </a:r>
-          </a:p>
-          <a:p>
-            <a:r>
-              <a:t>Dataset/DATASET.md</a:t>
+              <a:t>550 service cases, 450 damage.</a:t>
+            </a:r>
+          </a:p>
+          <a:p>
+            <a:r>
+              <a:t>- 41.3% of damage is parking or manoeuvring — high volume, low severity.</a:t>
+            </a:r>
+          </a:p>
+          <a:p>
+            <a:r>
+              <a:t>- 668 cases still open, median 150 days — a queue to review with the shop.</a:t>
+            </a:r>
+          </a:p>
+          <a:p>
+            <a:r>
+              <a:t>- Synthetic data: it describes this set, not the market. The notes stay German.</a:t>
             </a:r>
           </a:p>
         </p:txBody>
@@ -985,38 +982,27 @@
           <a:lstStyle/>
           <a:p>
             <a:r>
-              <a:t>60 seconds. Two protocols appear here. On the left, the DeepSeek extraction is evaluated on 977 cases, excluding the 3 prompt examples and the 20 pilot cases. Zones give 751 true positives, zero false positives and one false negative — an F1 of 99.93%. Case kind reaches 100%. Insurance reaches 100% on the 434 damage cases of this test. DeepSeek severity on those 434 cases is 68.7%, not to be compared directly with the table on the right. On the right, every model uses exactly the same 150 held-out ids for severity. The supervised models have 284 training examples. Verified counts: XGBoost 123/150, gbert 118/150, logistic regression 110/150, DeepSeek 109/150, LightGBM 98/150. These results describe a single split of the synthetic corpus. Recurring phrasings limit their reach. The lexical baseline also reaches 100% F1 on the zones of this corpus — so the scores do not prove a universal superiority of the LLM.</a:t>
-            </a:r>
-          </a:p>
-          <a:p/>
-          <a:p>
-            <a:r>
-              <a:t>Local sources:</a:t>
-            </a:r>
-          </a:p>
-          <a:p>
-            <a:r>
-              <a:t>Work/pipeline/eval_report.json</a:t>
-            </a:r>
-          </a:p>
-          <a:p>
-            <a:r>
-              <a:t>Work/pipeline/ml_split.json</a:t>
-            </a:r>
-          </a:p>
-          <a:p>
-            <a:r>
-              <a:t>Work/pipeline/gbert_result.json</a:t>
-            </a:r>
-          </a:p>
-          <a:p>
-            <a:r>
-              <a:t>Data/frontend/public/data/model_comparison.json</a:t>
-            </a:r>
-          </a:p>
-          <a:p>
-            <a:r>
-              <a:t>Work/pipeline/train_cpu_models.py</a:t>
+              <a:t>Two things measured here.</a:t>
+            </a:r>
+          </a:p>
+          <a:p>
+            <a:r>
+              <a:t>- Extraction on 977 unseen cases: zones F1 99.9%, case kind 100%, insurance 100% — every quote verbatim, nothing lost.</a:t>
+            </a:r>
+          </a:p>
+          <a:p>
+            <a:r>
+              <a:t>- Severity is the hard field: DeepSeek 68.7% on the 434 damage cases.</a:t>
+            </a:r>
+          </a:p>
+          <a:p>
+            <a:r>
+              <a:t>- Right: the 5-model shootout on the same 150 cases. Careful — a regex ties on zones; the LLM's real value is insurance and severity.</a:t>
+            </a:r>
+          </a:p>
+          <a:p>
+            <a:r>
+              <a:t>- The trained models win on synthetic data by memorizing the phrasings; they'd drop on real notes. We keep DeepSeek.</a:t>
             </a:r>
           </a:p>
         </p:txBody>
@@ -1093,33 +1079,27 @@
           <a:lstStyle/>
           <a:p>
             <a:r>
-              <a:t>45 seconds. Be explicit about the limits: the corpus is synthetic and reuses phrasings. Test ids are separate, but close phrasings can appear on both sides of the split. Validation by phrasing family, then on real notes, would be more convincing. The report shows the same stone-chip sentence can carry several severities. It estimates a 79.5% score for a text-fingerprint match on the full damage set: that estimate is specific to its method and scope, not a universal bound for the 150-case test (where the same method gives ~88.7%). We do not oppose it to XGBoost's 82%. Verbatim quotes and Pydantic enable auditing but do not guarantee semantic correctness. The R&amp;I and replacement rules have no ground-truth labels in this set. Next steps: measure latency and real cost, plus external validation on real notes. No financial figure is claimed.</a:t>
-            </a:r>
-          </a:p>
-          <a:p/>
-          <a:p>
-            <a:r>
-              <a:t>Local sources:</a:t>
-            </a:r>
-          </a:p>
-          <a:p>
-            <a:r>
-              <a:t>docs/jury-reliability-report.md</a:t>
-            </a:r>
-          </a:p>
-          <a:p>
-            <a:r>
-              <a:t>Work/pipeline/repair_logic.py</a:t>
-            </a:r>
-          </a:p>
-          <a:p>
-            <a:r>
-              <a:t>Dataset/DATASET.md</a:t>
-            </a:r>
-          </a:p>
-          <a:p>
-            <a:r>
-              <a:t>Work/pipeline/eval_report.json</a:t>
+              <a:t>Be upfront about the limits.</a:t>
+            </a:r>
+          </a:p>
+          <a:p>
+            <a:r>
+              <a:t>- Synthetic corpus reuses phrasings — a regex baseline looks strong on the zones.</a:t>
+            </a:r>
+          </a:p>
+          <a:p>
+            <a:r>
+              <a:t>- Severity has a data ceiling: the same sentence carries light, medium and severe labels.</a:t>
+            </a:r>
+          </a:p>
+          <a:p>
+            <a:r>
+              <a:t>- The key one: how do we know which parts to remove to repair another? From a hand-reviewed adjacency table — the dataset has no parts or removal labels, so it's expert rules, not measured. Mechanical R&amp;I (brakes → wheels) is out of scope.</a:t>
+            </a:r>
+          </a:p>
+          <a:p>
+            <a:r>
+              <a:t>- Next: validate on real production notes, and learn the R&amp;I table from repair-order histories.</a:t>
             </a:r>
           </a:p>
         </p:txBody>
@@ -1525,7 +1505,7 @@
         </p:nvSpPr>
         <p:spPr>
           <a:xfrm>
-            <a:off x="609600" y="409575"/>
+            <a:off x="2867025" y="61913"/>
             <a:ext cx="10953750" cy="714375"/>
           </a:xfrm>
           <a:prstGeom prst="rect">
@@ -1553,7 +1533,7 @@
               </a:defRPr>
             </a:pPr>
             <a:r>
-              <a:rPr sz="4800" b="1">
+              <a:rPr sz="4800" b="1" dirty="0">
                 <a:solidFill>
                   <a:srgbClr val="FFFFFF"/>
                 </a:solidFill>
@@ -1639,7 +1619,7 @@
         </p:nvSpPr>
         <p:spPr>
           <a:xfrm>
-            <a:off x="609600" y="1885950"/>
+            <a:off x="628650" y="1228725"/>
             <a:ext cx="5857875" cy="1485900"/>
           </a:xfrm>
           <a:prstGeom prst="rect">
@@ -1657,6 +1637,7 @@
           <a:lstStyle/>
           <a:p>
             <a:pPr>
+              <a:buNone/>
               <a:defRPr sz="3600" b="1">
                 <a:solidFill>
                   <a:srgbClr val="FFFFFF"/>
@@ -1667,7 +1648,7 @@
               </a:defRPr>
             </a:pPr>
             <a:r>
-              <a:rPr sz="3600" b="1" dirty="0">
+              <a:rPr lang="en-US" sz="3600" b="1" dirty="0">
                 <a:solidFill>
                   <a:srgbClr val="FFFFFF"/>
                 </a:solidFill>
@@ -1675,11 +1656,12 @@
                 <a:ea typeface="Arial"/>
                 <a:cs typeface="Arial"/>
               </a:rPr>
-              <a:t>Reading messy German workshop notes,</a:t>
-            </a:r>
-          </a:p>
-          <a:p>
-            <a:pPr>
+              <a:t>Prefer the product to the pipeline? </a:t>
+            </a:r>
+          </a:p>
+          <a:p>
+            <a:pPr>
+              <a:buNone/>
               <a:defRPr sz="3600" b="1">
                 <a:solidFill>
                   <a:srgbClr val="FFFFFF"/>
@@ -1690,7 +1672,7 @@
               </a:defRPr>
             </a:pPr>
             <a:r>
-              <a:rPr sz="3600" b="1" dirty="0">
+              <a:rPr lang="en-US" sz="3600" b="1" dirty="0">
                 <a:solidFill>
                   <a:srgbClr val="FFFFFF"/>
                 </a:solidFill>
@@ -1698,7 +1680,7 @@
                 <a:ea typeface="Arial"/>
                 <a:cs typeface="Arial"/>
               </a:rPr>
-              <a:t>one case at a time</a:t>
+              <a:t>Follow along on the live dashboard.</a:t>
             </a:r>
           </a:p>
         </p:txBody>
@@ -1719,8 +1701,8 @@
         </p:nvSpPr>
         <p:spPr>
           <a:xfrm>
-            <a:off x="504825" y="4057650"/>
-            <a:ext cx="10001250" cy="952500"/>
+            <a:off x="1123950" y="3667126"/>
+            <a:ext cx="5362575" cy="952500"/>
           </a:xfrm>
           <a:prstGeom prst="rect">
             <a:avLst/>
@@ -1736,7 +1718,8 @@
           </a:bodyPr>
           <a:lstStyle/>
           <a:p>
-            <a:pPr>
+            <a:pPr algn="ctr">
+              <a:buNone/>
               <a:defRPr sz="2325" b="0">
                 <a:solidFill>
                   <a:srgbClr val="B9D7D4"/>
@@ -1755,30 +1738,7 @@
                 <a:ea typeface="Arial"/>
                 <a:cs typeface="Arial"/>
               </a:rPr>
-              <a:t>A visual damage sheet per vehicle,</a:t>
-            </a:r>
-          </a:p>
-          <a:p>
-            <a:pPr>
-              <a:defRPr sz="2325" b="0">
-                <a:solidFill>
-                  <a:srgbClr val="B9D7D4"/>
-                </a:solidFill>
-                <a:latin typeface="Arial"/>
-                <a:ea typeface="Arial"/>
-                <a:cs typeface="Arial"/>
-              </a:defRPr>
-            </a:pPr>
-            <a:r>
-              <a:rPr lang="en-US" sz="2325" b="0" dirty="0">
-                <a:solidFill>
-                  <a:srgbClr val="B9D7D4"/>
-                </a:solidFill>
-                <a:latin typeface="Arial"/>
-                <a:ea typeface="Arial"/>
-                <a:cs typeface="Arial"/>
-              </a:rPr>
-              <a:t>and an operational read on 1,000 dealership cases</a:t>
+              <a:t>Mechanics write messy German notes; our app turns them into a clear per-car dashboard damage, severity, who pays, parts to replace.</a:t>
             </a:r>
           </a:p>
         </p:txBody>
@@ -1799,7 +1759,7 @@
         </p:nvSpPr>
         <p:spPr>
           <a:xfrm>
-            <a:off x="609600" y="5267325"/>
+            <a:off x="552450" y="5753100"/>
             <a:ext cx="8572500" cy="457200"/>
           </a:xfrm>
           <a:prstGeom prst="rect">
@@ -1836,85 +1796,6 @@
                 <a:cs typeface="Arial"/>
               </a:rPr>
               <a:t>1,000 synthetic cases · German kept in German</a:t>
-            </a:r>
-          </a:p>
-        </p:txBody>
-      </p:sp>
-      <p:sp>
-        <p:nvSpPr>
-          <p:cNvPr id="6" name="Rectangle 5">
-            <a:extLst>
-              <a:ext uri="{FF2B5EF4-FFF2-40B4-BE49-F238E27FC236}">
-                <a16:creationId xmlns:a16="http://schemas.microsoft.com/office/drawing/2014/main" id="{48B40988-B505-4F64-8226-EBD18CC71F5E}"/>
-              </a:ext>
-            </a:extLst>
-          </p:cNvPr>
-          <p:cNvSpPr>
-            <a:spLocks noGrp="1"/>
-          </p:cNvSpPr>
-          <p:nvPr/>
-        </p:nvSpPr>
-        <p:spPr>
-          <a:xfrm>
-            <a:off x="609600" y="5981700"/>
-            <a:ext cx="10001250" cy="333375"/>
-          </a:xfrm>
-          <a:prstGeom prst="rect">
-            <a:avLst/>
-          </a:prstGeom>
-          <a:noFill/>
-          <a:ln w="0">
-            <a:noFill/>
-          </a:ln>
-        </p:spPr>
-        <p:txBody>
-          <a:bodyPr>
-            <a:noAutofit/>
-          </a:bodyPr>
-          <a:lstStyle/>
-          <a:p>
-            <a:pPr>
-              <a:defRPr sz="1650" b="0">
-                <a:solidFill>
-                  <a:srgbClr val="B9D7D4"/>
-                </a:solidFill>
-                <a:latin typeface="Arial"/>
-                <a:ea typeface="Arial"/>
-                <a:cs typeface="Arial"/>
-              </a:defRPr>
-            </a:pPr>
-            <a:r>
-              <a:rPr sz="1650" b="0" dirty="0">
-                <a:solidFill>
-                  <a:srgbClr val="B9D7D4"/>
-                </a:solidFill>
-                <a:latin typeface="Arial"/>
-                <a:ea typeface="Arial"/>
-                <a:cs typeface="Arial"/>
-              </a:rPr>
-              <a:t>Wolf Day · </a:t>
-            </a:r>
-            <a:r>
-              <a:rPr sz="1650" b="0" dirty="0" err="1">
-                <a:solidFill>
-                  <a:srgbClr val="B9D7D4"/>
-                </a:solidFill>
-                <a:latin typeface="Arial"/>
-                <a:ea typeface="Arial"/>
-                <a:cs typeface="Arial"/>
-              </a:rPr>
-              <a:t>DaiL</a:t>
-            </a:r>
-            <a:r>
-              <a:rPr sz="1650" b="0" dirty="0">
-                <a:solidFill>
-                  <a:srgbClr val="B9D7D4"/>
-                </a:solidFill>
-                <a:latin typeface="Arial"/>
-                <a:ea typeface="Arial"/>
-                <a:cs typeface="Arial"/>
-              </a:rPr>
-              <a:t> · Track B</a:t>
             </a:r>
           </a:p>
         </p:txBody>
@@ -5128,63 +5009,6 @@
                 <a:cs typeface="Arial"/>
               </a:rPr>
               <a:t>06</a:t>
-            </a:r>
-          </a:p>
-        </p:txBody>
-      </p:sp>
-      <p:sp>
-        <p:nvSpPr>
-          <p:cNvPr id="3" name="Rectangle 2">
-            <a:extLst>
-              <a:ext uri="{FF2B5EF4-FFF2-40B4-BE49-F238E27FC236}">
-                <a16:creationId xmlns:a16="http://schemas.microsoft.com/office/drawing/2014/main" id="{0E181C90-9565-4CBE-99B0-94615C2FE127}"/>
-              </a:ext>
-            </a:extLst>
-          </p:cNvPr>
-          <p:cNvSpPr>
-            <a:spLocks noGrp="1"/>
-          </p:cNvSpPr>
-          <p:nvPr/>
-        </p:nvSpPr>
-        <p:spPr>
-          <a:xfrm>
-            <a:off x="609600" y="1466850"/>
-            <a:ext cx="6286500" cy="447675"/>
-          </a:xfrm>
-          <a:prstGeom prst="rect">
-            <a:avLst/>
-          </a:prstGeom>
-          <a:noFill/>
-          <a:ln w="0">
-            <a:noFill/>
-          </a:ln>
-        </p:spPr>
-        <p:txBody>
-          <a:bodyPr>
-            <a:noAutofit/>
-          </a:bodyPr>
-          <a:lstStyle/>
-          <a:p>
-            <a:pPr>
-              <a:defRPr sz="2250" b="1">
-                <a:solidFill>
-                  <a:srgbClr val="102C36"/>
-                </a:solidFill>
-                <a:latin typeface="Arial"/>
-                <a:ea typeface="Arial"/>
-                <a:cs typeface="Arial"/>
-              </a:defRPr>
-            </a:pPr>
-            <a:r>
-              <a:rPr sz="2250" b="1">
-                <a:solidFill>
-                  <a:srgbClr val="102C36"/>
-                </a:solidFill>
-                <a:latin typeface="Arial"/>
-                <a:ea typeface="Arial"/>
-                <a:cs typeface="Arial"/>
-              </a:rPr>
-              <a:t>The question the jury pressed on</a:t>
             </a:r>
           </a:p>
         </p:txBody>

</xml_diff>